<commit_message>
Add Entrega 2 documents
</commit_message>
<xml_diff>
--- a/documentos/BANNER_FECAP_1MACCOMP_CADD_2026_1.pptx
+++ b/documentos/BANNER_FECAP_1MACCOMP_CADD_2026_1.pptx
@@ -21,10 +21,11 @@
       <p:boldItalic r:id="rId7"/>
     </p:embeddedFont>
     <p:embeddedFont>
-      <p:font typeface="Open Sans" panose="020B0606030504020204" pitchFamily="34" charset="0"/>
-      <p:bold r:id="rId8"/>
-      <p:italic r:id="rId9"/>
-      <p:boldItalic r:id="rId10"/>
+      <p:font typeface="Open Sans" pitchFamily="2" charset="0"/>
+      <p:regular r:id="rId8"/>
+      <p:bold r:id="rId9"/>
+      <p:italic r:id="rId10"/>
+      <p:boldItalic r:id="rId11"/>
     </p:embeddedFont>
   </p:embeddedFontLst>
   <p:defaultTextStyle>
@@ -272,7 +273,7 @@
       </p15:sldGuideLst>
     </p:ext>
     <p:ext uri="GoogleSlidesCustomDataVersion2">
-      <go:slidesCustomData xmlns:go="http://customooxmlschemas.google.com/" xmlns:ahyp="http://schemas.microsoft.com/office/drawing/2018/hyperlinkcolor" xmlns:p15="http://schemas.microsoft.com/office/powerpoint/2012/main" xmlns:p14="http://schemas.microsoft.com/office/powerpoint/2010/main" xmlns:com="http://schemas.openxmlformats.org/drawingml/2006/compatibility" xmlns:pvml="urn:schemas-microsoft-com:office:powerpoint" xmlns:v="urn:schemas-microsoft-com:vml" xmlns:o="urn:schemas-microsoft-com:office:office" xmlns:dgm="http://schemas.openxmlformats.org/drawingml/2006/diagram" xmlns:c="http://schemas.openxmlformats.org/drawingml/2006/chart" xmlns:mv="urn:schemas-microsoft-com:mac:vml" xmlns:mc="http://schemas.openxmlformats.org/markup-compatibility/2006" xmlns="" r:id="rId13" roundtripDataSignature="AMtx7mi+9yr4mDS8zg5+kfXTqvtBuST67g=="/>
+      <go:slidesCustomData xmlns="" xmlns:mc="http://schemas.openxmlformats.org/markup-compatibility/2006" xmlns:mv="urn:schemas-microsoft-com:mac:vml" xmlns:c="http://schemas.openxmlformats.org/drawingml/2006/chart" xmlns:dgm="http://schemas.openxmlformats.org/drawingml/2006/diagram" xmlns:o="urn:schemas-microsoft-com:office:office" xmlns:v="urn:schemas-microsoft-com:vml" xmlns:pvml="urn:schemas-microsoft-com:office:powerpoint" xmlns:com="http://schemas.openxmlformats.org/drawingml/2006/compatibility" xmlns:p14="http://schemas.microsoft.com/office/powerpoint/2010/main" xmlns:p15="http://schemas.microsoft.com/office/powerpoint/2012/main" xmlns:ahyp="http://schemas.microsoft.com/office/drawing/2018/hyperlinkcolor" xmlns:go="http://customooxmlschemas.google.com/" r:id="rId13" roundtripDataSignature="AMtx7mi+9yr4mDS8zg5+kfXTqvtBuST67g=="/>
     </p:ext>
   </p:extLst>
 </p:presentation>
@@ -12019,9 +12020,9 @@
                   <a:solidFill>
                     <a:srgbClr val="000000"/>
                   </a:solidFill>
-                  <a:latin typeface="Open Sans"/>
-                  <a:ea typeface="Open Sans"/>
-                  <a:cs typeface="Open Sans"/>
+                  <a:latin typeface="Open Sans ExtraBold"/>
+                  <a:ea typeface="Open Sans ExtraBold"/>
+                  <a:cs typeface="Open Sans ExtraBold"/>
                   <a:sym typeface="Open Sans"/>
                 </a:rPr>
                 <a:t>REFERÊNCIAS</a:t>
@@ -12304,9 +12305,9 @@
                 <a:solidFill>
                   <a:srgbClr val="000000"/>
                 </a:solidFill>
-                <a:latin typeface="Open Sans"/>
-                <a:ea typeface="Open Sans"/>
-                <a:cs typeface="Open Sans"/>
+                <a:latin typeface="Open Sans ExtraBold"/>
+                <a:ea typeface="Open Sans ExtraBold"/>
+                <a:cs typeface="Open Sans ExtraBold"/>
                 <a:sym typeface="Open Sans"/>
               </a:rPr>
               <a:t>INTRODUÇÃO</a:t>
@@ -12709,21 +12710,9 @@
             </a:pPr>
             <a:r>
               <a:rPr lang="pt-BR" sz="11434" b="1" noProof="1">
-                <a:solidFill>
-                  <a:srgbClr val="000000"/>
-                </a:solidFill>
-                <a:latin typeface="Open Sans"/>
-                <a:ea typeface="Open Sans"/>
-                <a:cs typeface="Open Sans"/>
-                <a:sym typeface="Open Sans"/>
-              </a:rPr>
-              <a:t>PROJETO </a:t>
-            </a:r>
-            <a:r>
-              <a:rPr lang="pt-BR" sz="11434" b="1" noProof="1">
-                <a:latin typeface="Open Sans"/>
-                <a:ea typeface="Open Sans"/>
-                <a:cs typeface="Open Sans"/>
+                <a:latin typeface="Open Sans ExtraBold"/>
+                <a:ea typeface="Open Sans ExtraBold"/>
+                <a:cs typeface="Open Sans ExtraBold"/>
                 <a:sym typeface="Open Sans"/>
               </a:rPr>
               <a:t>URBAN CHASE</a:t>
@@ -12774,9 +12763,9 @@
                 <a:solidFill>
                   <a:srgbClr val="000000"/>
                 </a:solidFill>
-                <a:latin typeface="Open Sans"/>
-                <a:ea typeface="Open Sans"/>
-                <a:cs typeface="Open Sans"/>
+                <a:latin typeface="Open Sans ExtraBold"/>
+                <a:ea typeface="Open Sans ExtraBold"/>
+                <a:cs typeface="Open Sans ExtraBold"/>
                 <a:sym typeface="Open Sans"/>
               </a:rPr>
               <a:t>André Makoto, Caio Fabio, Davi Varella, Davi Moraes</a:t>
@@ -12790,27 +12779,31 @@
               </a:lnSpc>
             </a:pPr>
             <a:r>
-              <a:rPr lang="pt-BR" sz="4762" b="1" noProof="1">
+              <a:rPr lang="pt-BR" sz="4762" noProof="1">
                 <a:solidFill>
                   <a:srgbClr val="000000"/>
                 </a:solidFill>
-                <a:latin typeface="Open Sans"/>
-                <a:ea typeface="Open Sans"/>
-                <a:cs typeface="Open Sans"/>
+                <a:latin typeface="Open Sans Light" pitchFamily="2" charset="0"/>
+                <a:ea typeface="Open Sans Light" pitchFamily="2" charset="0"/>
+                <a:cs typeface="Open Sans Light" pitchFamily="2" charset="0"/>
                 <a:sym typeface="Open Sans"/>
               </a:rPr>
               <a:t>Orientadores</a:t>
             </a:r>
             <a:r>
-              <a:rPr lang="pt-BR" sz="4762" b="1" noProof="1">
-                <a:latin typeface="Open Sans"/>
-                <a:ea typeface="Open Sans"/>
-                <a:cs typeface="Open Sans"/>
+              <a:rPr lang="pt-BR" sz="4762" noProof="1">
+                <a:latin typeface="Open Sans Light" pitchFamily="2" charset="0"/>
+                <a:ea typeface="Open Sans Light" pitchFamily="2" charset="0"/>
+                <a:cs typeface="Open Sans Light" pitchFamily="2" charset="0"/>
                 <a:sym typeface="Open Sans"/>
               </a:rPr>
-              <a:t>: Adriano Felix, David de Oliveira, Eduardo Savino, Renata Muniz, Victor Rosetti </a:t>
+              <a:t>: Adriano Felix, David de Oliveira, Eduardo Savino, Luis Pires Renata Muniz, Victor Rosetti </a:t>
             </a:r>
-            <a:endParaRPr lang="pt-BR" noProof="1"/>
+            <a:endParaRPr lang="pt-BR" noProof="1">
+              <a:latin typeface="Open Sans Light" pitchFamily="2" charset="0"/>
+              <a:ea typeface="Open Sans Light" pitchFamily="2" charset="0"/>
+              <a:cs typeface="Open Sans Light" pitchFamily="2" charset="0"/>
+            </a:endParaRPr>
           </a:p>
         </p:txBody>
       </p:sp>
@@ -12853,15 +12846,6 @@
             </a:pPr>
             <a:r>
               <a:rPr lang="pt-BR" sz="3430" noProof="1">
-                <a:latin typeface="Inter"/>
-                <a:ea typeface="Inter"/>
-                <a:cs typeface="Inter"/>
-                <a:sym typeface="Inter"/>
-              </a:rPr>
-              <a:t>Fase 1</a:t>
-            </a:r>
-            <a:r>
-              <a:rPr lang="pt-BR" sz="3430" noProof="1">
                 <a:solidFill>
                   <a:srgbClr val="000000"/>
                 </a:solidFill>
@@ -12870,7 +12854,7 @@
                 <a:cs typeface="Inter"/>
                 <a:sym typeface="Inter"/>
               </a:rPr>
-              <a:t>: Urban Chase</a:t>
+              <a:t>Cena Planejamento: Urban Chase</a:t>
             </a:r>
             <a:endParaRPr lang="pt-BR" noProof="1"/>
           </a:p>
@@ -12971,9 +12955,9 @@
                 <a:solidFill>
                   <a:srgbClr val="000000"/>
                 </a:solidFill>
-                <a:latin typeface="Open Sans"/>
-                <a:ea typeface="Open Sans"/>
-                <a:cs typeface="Open Sans"/>
+                <a:latin typeface="Open Sans ExtraBold"/>
+                <a:ea typeface="Open Sans ExtraBold"/>
+                <a:cs typeface="Open Sans ExtraBold"/>
                 <a:sym typeface="Open Sans"/>
               </a:rPr>
               <a:t>TECNOLOGIAS UTILIZADAS</a:t>
@@ -13024,9 +13008,9 @@
                 <a:solidFill>
                   <a:srgbClr val="000000"/>
                 </a:solidFill>
-                <a:latin typeface="Open Sans"/>
-                <a:ea typeface="Open Sans"/>
-                <a:cs typeface="Open Sans"/>
+                <a:latin typeface="Open Sans ExtraBold"/>
+                <a:ea typeface="Open Sans ExtraBold"/>
+                <a:cs typeface="Open Sans ExtraBold"/>
                 <a:sym typeface="Open Sans"/>
               </a:rPr>
               <a:t>RESULTADOS</a:t>
@@ -13077,9 +13061,9 @@
                 <a:solidFill>
                   <a:srgbClr val="000000"/>
                 </a:solidFill>
-                <a:latin typeface="Open Sans"/>
-                <a:ea typeface="Open Sans"/>
-                <a:cs typeface="Open Sans"/>
+                <a:latin typeface="Open Sans ExtraBold"/>
+                <a:ea typeface="Open Sans ExtraBold"/>
+                <a:cs typeface="Open Sans ExtraBold"/>
                 <a:sym typeface="Open Sans"/>
               </a:rPr>
               <a:t>O PROBLEMA</a:t>
@@ -13130,9 +13114,9 @@
                 <a:solidFill>
                   <a:srgbClr val="000000"/>
                 </a:solidFill>
-                <a:latin typeface="Open Sans"/>
-                <a:ea typeface="Open Sans"/>
-                <a:cs typeface="Open Sans"/>
+                <a:latin typeface="Open Sans ExtraBold"/>
+                <a:ea typeface="Open Sans ExtraBold"/>
+                <a:cs typeface="Open Sans ExtraBold"/>
                 <a:sym typeface="Open Sans"/>
               </a:rPr>
               <a:t>A PROPOSTA</a:t>
@@ -13173,9 +13157,9 @@
             </a:pPr>
             <a:r>
               <a:rPr lang="pt-BR" sz="3200" noProof="1">
-                <a:latin typeface="Open Sans" panose="020B0606030504020204" pitchFamily="34" charset="0"/>
-                <a:ea typeface="Open Sans" panose="020B0606030504020204" pitchFamily="34" charset="0"/>
-                <a:cs typeface="Open Sans" panose="020B0606030504020204" pitchFamily="34" charset="0"/>
+                <a:latin typeface="Open Sans Light" panose="020B0606030504020204" pitchFamily="34" charset="0"/>
+                <a:ea typeface="Open Sans Light" panose="020B0606030504020204" pitchFamily="34" charset="0"/>
+                <a:cs typeface="Open Sans Light" panose="020B0606030504020204" pitchFamily="34" charset="0"/>
               </a:rPr>
               <a:t>SILICON &amp; SYNAPSE. Rock 'n' Roll Racing. Publicado por Interplay Productions. Super Nintendo Entertainment System, 1993.</a:t>
             </a:r>
@@ -13187,9 +13171,9 @@
               </a:lnSpc>
             </a:pPr>
             <a:endParaRPr lang="pt-BR" sz="3200" noProof="1">
-              <a:latin typeface="Open Sans" panose="020B0606030504020204" pitchFamily="34" charset="0"/>
-              <a:ea typeface="Open Sans" panose="020B0606030504020204" pitchFamily="34" charset="0"/>
-              <a:cs typeface="Open Sans" panose="020B0606030504020204" pitchFamily="34" charset="0"/>
+              <a:latin typeface="Open Sans Light" panose="020B0606030504020204" pitchFamily="34" charset="0"/>
+              <a:ea typeface="Open Sans Light" panose="020B0606030504020204" pitchFamily="34" charset="0"/>
+              <a:cs typeface="Open Sans Light" panose="020B0606030504020204" pitchFamily="34" charset="0"/>
             </a:endParaRPr>
           </a:p>
           <a:p>
@@ -13200,9 +13184,9 @@
             </a:pPr>
             <a:r>
               <a:rPr lang="pt-BR" sz="3200" noProof="1">
-                <a:latin typeface="Open Sans" panose="020B0606030504020204" pitchFamily="34" charset="0"/>
-                <a:ea typeface="Open Sans" panose="020B0606030504020204" pitchFamily="34" charset="0"/>
-                <a:cs typeface="Open Sans" panose="020B0606030504020204" pitchFamily="34" charset="0"/>
+                <a:latin typeface="Open Sans Light" panose="020B0606030504020204" pitchFamily="34" charset="0"/>
+                <a:ea typeface="Open Sans Light" panose="020B0606030504020204" pitchFamily="34" charset="0"/>
+                <a:cs typeface="Open Sans Light" panose="020B0606030504020204" pitchFamily="34" charset="0"/>
               </a:rPr>
               <a:t>YGGBRASIL EDUCAÇÃO DO FUTURO. Criando um projeto com Unity 6. [S.l.]: YouTube, 2025. Disponível em: https://youtube.com/watch?v=TBUJWUvc1Eg. Acesso em: 27 mar. 2026.</a:t>
             </a:r>
@@ -13236,25 +13220,25 @@
           <a:p>
             <a:r>
               <a:rPr lang="pt-BR" sz="3430" dirty="0">
-                <a:latin typeface="Open Sans" panose="020B0606030504020204" pitchFamily="34" charset="0"/>
-                <a:ea typeface="Open Sans" panose="020B0606030504020204" pitchFamily="34" charset="0"/>
-                <a:cs typeface="Open Sans" panose="020B0606030504020204" pitchFamily="34" charset="0"/>
+                <a:latin typeface="Open Sans Light" panose="020B0606030504020204" pitchFamily="34" charset="0"/>
+                <a:ea typeface="Open Sans Light" panose="020B0606030504020204" pitchFamily="34" charset="0"/>
+                <a:cs typeface="Open Sans Light" panose="020B0606030504020204" pitchFamily="34" charset="0"/>
               </a:rPr>
               <a:t>O jogo foi desenvolvido utilizando a </a:t>
             </a:r>
             <a:r>
               <a:rPr lang="pt-BR" sz="3430" dirty="0" err="1">
-                <a:latin typeface="Open Sans" panose="020B0606030504020204" pitchFamily="34" charset="0"/>
-                <a:ea typeface="Open Sans" panose="020B0606030504020204" pitchFamily="34" charset="0"/>
-                <a:cs typeface="Open Sans" panose="020B0606030504020204" pitchFamily="34" charset="0"/>
+                <a:latin typeface="Open Sans Light" panose="020B0606030504020204" pitchFamily="34" charset="0"/>
+                <a:ea typeface="Open Sans Light" panose="020B0606030504020204" pitchFamily="34" charset="0"/>
+                <a:cs typeface="Open Sans Light" panose="020B0606030504020204" pitchFamily="34" charset="0"/>
               </a:rPr>
               <a:t>engine</a:t>
             </a:r>
             <a:r>
               <a:rPr lang="pt-BR" sz="3430" dirty="0">
-                <a:latin typeface="Open Sans" panose="020B0606030504020204" pitchFamily="34" charset="0"/>
-                <a:ea typeface="Open Sans" panose="020B0606030504020204" pitchFamily="34" charset="0"/>
-                <a:cs typeface="Open Sans" panose="020B0606030504020204" pitchFamily="34" charset="0"/>
+                <a:latin typeface="Open Sans Light" panose="020B0606030504020204" pitchFamily="34" charset="0"/>
+                <a:ea typeface="Open Sans Light" panose="020B0606030504020204" pitchFamily="34" charset="0"/>
+                <a:cs typeface="Open Sans Light" panose="020B0606030504020204" pitchFamily="34" charset="0"/>
               </a:rPr>
               <a:t> Unity com programação em C#, suportando toda a lógica de perseguição, física e interação com o ambiente urbano.</a:t>
             </a:r>
@@ -13266,9 +13250,9 @@
             </a:pPr>
             <a:r>
               <a:rPr lang="pt-BR" sz="3430" dirty="0">
-                <a:latin typeface="Open Sans" panose="020B0606030504020204" pitchFamily="34" charset="0"/>
-                <a:ea typeface="Open Sans" panose="020B0606030504020204" pitchFamily="34" charset="0"/>
-                <a:cs typeface="Open Sans" panose="020B0606030504020204" pitchFamily="34" charset="0"/>
+                <a:latin typeface="Open Sans Light" panose="020B0606030504020204" pitchFamily="34" charset="0"/>
+                <a:ea typeface="Open Sans Light" panose="020B0606030504020204" pitchFamily="34" charset="0"/>
+                <a:cs typeface="Open Sans Light" panose="020B0606030504020204" pitchFamily="34" charset="0"/>
               </a:rPr>
               <a:t>Unity </a:t>
             </a:r>
@@ -13280,9 +13264,9 @@
             </a:pPr>
             <a:r>
               <a:rPr lang="pt-BR" sz="3430" dirty="0">
-                <a:latin typeface="Open Sans" panose="020B0606030504020204" pitchFamily="34" charset="0"/>
-                <a:ea typeface="Open Sans" panose="020B0606030504020204" pitchFamily="34" charset="0"/>
-                <a:cs typeface="Open Sans" panose="020B0606030504020204" pitchFamily="34" charset="0"/>
+                <a:latin typeface="Open Sans Light" panose="020B0606030504020204" pitchFamily="34" charset="0"/>
+                <a:ea typeface="Open Sans Light" panose="020B0606030504020204" pitchFamily="34" charset="0"/>
+                <a:cs typeface="Open Sans Light" panose="020B0606030504020204" pitchFamily="34" charset="0"/>
               </a:rPr>
               <a:t>C#</a:t>
             </a:r>
@@ -13294,9 +13278,9 @@
             </a:pPr>
             <a:r>
               <a:rPr lang="pt-BR" sz="3430" dirty="0">
-                <a:latin typeface="Open Sans" panose="020B0606030504020204" pitchFamily="34" charset="0"/>
-                <a:ea typeface="Open Sans" panose="020B0606030504020204" pitchFamily="34" charset="0"/>
-                <a:cs typeface="Open Sans" panose="020B0606030504020204" pitchFamily="34" charset="0"/>
+                <a:latin typeface="Open Sans Light" panose="020B0606030504020204" pitchFamily="34" charset="0"/>
+                <a:ea typeface="Open Sans Light" panose="020B0606030504020204" pitchFamily="34" charset="0"/>
+                <a:cs typeface="Open Sans Light" panose="020B0606030504020204" pitchFamily="34" charset="0"/>
               </a:rPr>
               <a:t>GitHub </a:t>
             </a:r>
@@ -13308,17 +13292,17 @@
             </a:pPr>
             <a:r>
               <a:rPr lang="pt-BR" sz="3430" dirty="0" err="1">
-                <a:latin typeface="Open Sans" panose="020B0606030504020204" pitchFamily="34" charset="0"/>
-                <a:ea typeface="Open Sans" panose="020B0606030504020204" pitchFamily="34" charset="0"/>
-                <a:cs typeface="Open Sans" panose="020B0606030504020204" pitchFamily="34" charset="0"/>
+                <a:latin typeface="Open Sans Light" panose="020B0606030504020204" pitchFamily="34" charset="0"/>
+                <a:ea typeface="Open Sans Light" panose="020B0606030504020204" pitchFamily="34" charset="0"/>
+                <a:cs typeface="Open Sans Light" panose="020B0606030504020204" pitchFamily="34" charset="0"/>
               </a:rPr>
               <a:t>Kanban</a:t>
             </a:r>
             <a:r>
               <a:rPr lang="pt-BR" sz="3430" dirty="0">
-                <a:latin typeface="Open Sans" panose="020B0606030504020204" pitchFamily="34" charset="0"/>
-                <a:ea typeface="Open Sans" panose="020B0606030504020204" pitchFamily="34" charset="0"/>
-                <a:cs typeface="Open Sans" panose="020B0606030504020204" pitchFamily="34" charset="0"/>
+                <a:latin typeface="Open Sans Light" panose="020B0606030504020204" pitchFamily="34" charset="0"/>
+                <a:ea typeface="Open Sans Light" panose="020B0606030504020204" pitchFamily="34" charset="0"/>
+                <a:cs typeface="Open Sans Light" panose="020B0606030504020204" pitchFamily="34" charset="0"/>
               </a:rPr>
               <a:t> </a:t>
             </a:r>
@@ -13330,17 +13314,17 @@
             </a:pPr>
             <a:r>
               <a:rPr lang="pt-BR" sz="3430" dirty="0" err="1">
-                <a:latin typeface="Open Sans" panose="020B0606030504020204" pitchFamily="34" charset="0"/>
-                <a:ea typeface="Open Sans" panose="020B0606030504020204" pitchFamily="34" charset="0"/>
-                <a:cs typeface="Open Sans" panose="020B0606030504020204" pitchFamily="34" charset="0"/>
+                <a:latin typeface="Open Sans Light" panose="020B0606030504020204" pitchFamily="34" charset="0"/>
+                <a:ea typeface="Open Sans Light" panose="020B0606030504020204" pitchFamily="34" charset="0"/>
+                <a:cs typeface="Open Sans Light" panose="020B0606030504020204" pitchFamily="34" charset="0"/>
               </a:rPr>
               <a:t>Notion</a:t>
             </a:r>
             <a:r>
               <a:rPr lang="pt-BR" sz="3430" dirty="0">
-                <a:latin typeface="Open Sans" panose="020B0606030504020204" pitchFamily="34" charset="0"/>
-                <a:ea typeface="Open Sans" panose="020B0606030504020204" pitchFamily="34" charset="0"/>
-                <a:cs typeface="Open Sans" panose="020B0606030504020204" pitchFamily="34" charset="0"/>
+                <a:latin typeface="Open Sans Light" panose="020B0606030504020204" pitchFamily="34" charset="0"/>
+                <a:ea typeface="Open Sans Light" panose="020B0606030504020204" pitchFamily="34" charset="0"/>
+                <a:cs typeface="Open Sans Light" panose="020B0606030504020204" pitchFamily="34" charset="0"/>
               </a:rPr>
               <a:t> </a:t>
             </a:r>
@@ -13352,9 +13336,9 @@
             </a:pPr>
             <a:r>
               <a:rPr lang="pt-BR" sz="3430" dirty="0">
-                <a:latin typeface="Open Sans" panose="020B0606030504020204" pitchFamily="34" charset="0"/>
-                <a:ea typeface="Open Sans" panose="020B0606030504020204" pitchFamily="34" charset="0"/>
-                <a:cs typeface="Open Sans" panose="020B0606030504020204" pitchFamily="34" charset="0"/>
+                <a:latin typeface="Open Sans Light" panose="020B0606030504020204" pitchFamily="34" charset="0"/>
+                <a:ea typeface="Open Sans Light" panose="020B0606030504020204" pitchFamily="34" charset="0"/>
+                <a:cs typeface="Open Sans Light" panose="020B0606030504020204" pitchFamily="34" charset="0"/>
               </a:rPr>
               <a:t>Claude IA</a:t>
             </a:r>
@@ -13362,9 +13346,9 @@
           <a:p>
             <a:r>
               <a:rPr lang="pt-BR" sz="3430" dirty="0">
-                <a:latin typeface="Open Sans" panose="020B0606030504020204" pitchFamily="34" charset="0"/>
-                <a:ea typeface="Open Sans" panose="020B0606030504020204" pitchFamily="34" charset="0"/>
-                <a:cs typeface="Open Sans" panose="020B0606030504020204" pitchFamily="34" charset="0"/>
+                <a:latin typeface="Open Sans Light" panose="020B0606030504020204" pitchFamily="34" charset="0"/>
+                <a:ea typeface="Open Sans Light" panose="020B0606030504020204" pitchFamily="34" charset="0"/>
+                <a:cs typeface="Open Sans Light" panose="020B0606030504020204" pitchFamily="34" charset="0"/>
               </a:rPr>
               <a:t>Controle de versão, gestão de tarefas, organização do projeto e suporte com inteligência artificial integrados ao fluxo de desenvolvimento.</a:t>
             </a:r>
@@ -13403,9 +13387,9 @@
             </a:pPr>
             <a:r>
               <a:rPr lang="pt-BR" sz="3430" dirty="0">
-                <a:latin typeface="Open Sans" panose="020B0606030504020204" pitchFamily="34" charset="0"/>
-                <a:ea typeface="Open Sans" panose="020B0606030504020204" pitchFamily="34" charset="0"/>
-                <a:cs typeface="Open Sans" panose="020B0606030504020204" pitchFamily="34" charset="0"/>
+                <a:latin typeface="Open Sans Light" panose="020B0606030504020204" pitchFamily="34" charset="0"/>
+                <a:ea typeface="Open Sans Light" panose="020B0606030504020204" pitchFamily="34" charset="0"/>
+                <a:cs typeface="Open Sans Light" panose="020B0606030504020204" pitchFamily="34" charset="0"/>
               </a:rPr>
               <a:t>A depredação do patrimônio público gera prejuízos diretos à coletividade, comprometendo recursos e serviços que pertencem a todos. Monumentos, vias e equipamentos urbanos danificados representam custos que recaem sobre a população, degradando a qualidade de vida nas cidades e afastando investimentos do espaço urbano. Agentes de segurança, por sua vez, enfrentam o desafio cotidiano de conter essas ocorrências sem agravar ainda mais os danos ao ambiente e às pessoas ao redor, precisando tomar decisões rápidas e precisas em situações imprevisíveis onde qualquer erro tem consequências coletivas.</a:t>
             </a:r>
@@ -13413,9 +13397,9 @@
               <a:solidFill>
                 <a:srgbClr val="000000"/>
               </a:solidFill>
-              <a:latin typeface="Open Sans" panose="020B0606030504020204" pitchFamily="34" charset="0"/>
-              <a:ea typeface="Open Sans" panose="020B0606030504020204" pitchFamily="34" charset="0"/>
-              <a:cs typeface="Open Sans" panose="020B0606030504020204" pitchFamily="34" charset="0"/>
+              <a:latin typeface="Open Sans Light" panose="020B0606030504020204" pitchFamily="34" charset="0"/>
+              <a:ea typeface="Open Sans Light" panose="020B0606030504020204" pitchFamily="34" charset="0"/>
+              <a:cs typeface="Open Sans Light" panose="020B0606030504020204" pitchFamily="34" charset="0"/>
               <a:sym typeface="Open Sans"/>
             </a:endParaRPr>
           </a:p>
@@ -13453,24 +13437,24 @@
             </a:pPr>
             <a:r>
               <a:rPr lang="pt-BR" sz="3430" dirty="0" err="1">
-                <a:latin typeface="Open Sans" panose="020B0606030504020204" pitchFamily="34" charset="0"/>
-                <a:ea typeface="Open Sans" panose="020B0606030504020204" pitchFamily="34" charset="0"/>
-                <a:cs typeface="Open Sans" panose="020B0606030504020204" pitchFamily="34" charset="0"/>
+                <a:latin typeface="Open Sans Light" panose="020B0606030504020204" pitchFamily="34" charset="0"/>
+                <a:ea typeface="Open Sans Light" panose="020B0606030504020204" pitchFamily="34" charset="0"/>
+                <a:cs typeface="Open Sans Light" panose="020B0606030504020204" pitchFamily="34" charset="0"/>
               </a:rPr>
               <a:t>Urban</a:t>
             </a:r>
             <a:r>
               <a:rPr lang="pt-BR" sz="3430" dirty="0">
-                <a:latin typeface="Open Sans" panose="020B0606030504020204" pitchFamily="34" charset="0"/>
-                <a:ea typeface="Open Sans" panose="020B0606030504020204" pitchFamily="34" charset="0"/>
-                <a:cs typeface="Open Sans" panose="020B0606030504020204" pitchFamily="34" charset="0"/>
+                <a:latin typeface="Open Sans Light" panose="020B0606030504020204" pitchFamily="34" charset="0"/>
+                <a:ea typeface="Open Sans Light" panose="020B0606030504020204" pitchFamily="34" charset="0"/>
+                <a:cs typeface="Open Sans Light" panose="020B0606030504020204" pitchFamily="34" charset="0"/>
               </a:rPr>
               <a:t> Chase é um jogo 3D em terceira pessoa que coloca o jogador no papel do Detetive Paul, um agente responsável por interceptar um fugitivo em ambiente urbano utilizando estratégia e raciocínio tático. Por meio de mecânicas de ponto e clique, o jogador posiciona obstáculos no cenário para conter o avanço do vândalo, vivenciando na prática a dificuldade de agir com eficiência sem causar danos colaterais à cidade e aos cidadãos. Essa experiência gamificada promove a conscientização sobre os impactos individuais e coletivos da depredação do patrimônio público, unindo entretenimento e reflexão social.</a:t>
             </a:r>
             <a:endParaRPr lang="pt-BR" sz="3430" noProof="1">
-              <a:latin typeface="Open Sans" panose="020B0606030504020204" pitchFamily="34" charset="0"/>
-              <a:ea typeface="Open Sans" panose="020B0606030504020204" pitchFamily="34" charset="0"/>
-              <a:cs typeface="Open Sans" panose="020B0606030504020204" pitchFamily="34" charset="0"/>
+              <a:latin typeface="Open Sans Light" panose="020B0606030504020204" pitchFamily="34" charset="0"/>
+              <a:ea typeface="Open Sans Light" panose="020B0606030504020204" pitchFamily="34" charset="0"/>
+              <a:cs typeface="Open Sans Light" panose="020B0606030504020204" pitchFamily="34" charset="0"/>
             </a:endParaRPr>
           </a:p>
         </p:txBody>
@@ -13514,9 +13498,9 @@
             </a:pPr>
             <a:r>
               <a:rPr lang="pt-BR" sz="4955" b="1" noProof="1">
-                <a:latin typeface="Open Sans"/>
-                <a:ea typeface="Open Sans"/>
-                <a:cs typeface="Open Sans"/>
+                <a:latin typeface="Open Sans ExtraBold"/>
+                <a:ea typeface="Open Sans ExtraBold"/>
+                <a:cs typeface="Open Sans ExtraBold"/>
                 <a:sym typeface="Open Sans"/>
               </a:rPr>
               <a:t>IV </a:t>
@@ -13526,9 +13510,9 @@
                 <a:solidFill>
                   <a:srgbClr val="000000"/>
                 </a:solidFill>
-                <a:latin typeface="Open Sans"/>
-                <a:ea typeface="Open Sans"/>
-                <a:cs typeface="Open Sans"/>
+                <a:latin typeface="Open Sans ExtraBold"/>
+                <a:ea typeface="Open Sans ExtraBold"/>
+                <a:cs typeface="Open Sans ExtraBold"/>
                 <a:sym typeface="Open Sans"/>
               </a:rPr>
               <a:t>SEMANA FECAP DE TECNOLOGIA - 2026</a:t>
@@ -13553,9 +13537,9 @@
                 <a:solidFill>
                   <a:srgbClr val="000000"/>
                 </a:solidFill>
-                <a:latin typeface="Open Sans"/>
-                <a:ea typeface="Open Sans"/>
-                <a:cs typeface="Open Sans"/>
+                <a:latin typeface="Open Sans Light"/>
+                <a:ea typeface="Open Sans Light"/>
+                <a:cs typeface="Open Sans Light"/>
                 <a:sym typeface="Open Sans"/>
               </a:rPr>
               <a:t>Fundação Escola de Comércio Álvares Penteado - FECAP</a:t>
@@ -13592,41 +13576,41 @@
             <a:pPr algn="just"/>
             <a:r>
               <a:rPr lang="pt-BR" sz="3430" dirty="0">
-                <a:latin typeface="Open Sans" panose="020B0606030504020204" pitchFamily="34" charset="0"/>
-                <a:ea typeface="Open Sans" panose="020B0606030504020204" pitchFamily="34" charset="0"/>
-                <a:cs typeface="Open Sans" panose="020B0606030504020204" pitchFamily="34" charset="0"/>
+                <a:latin typeface="Open Sans Light" panose="020B0606030504020204" pitchFamily="34" charset="0"/>
+                <a:ea typeface="Open Sans Light" panose="020B0606030504020204" pitchFamily="34" charset="0"/>
+                <a:cs typeface="Open Sans Light" panose="020B0606030504020204" pitchFamily="34" charset="0"/>
               </a:rPr>
               <a:t>O game </a:t>
             </a:r>
             <a:r>
               <a:rPr lang="pt-BR" sz="3430" dirty="0" err="1">
-                <a:latin typeface="Open Sans" panose="020B0606030504020204" pitchFamily="34" charset="0"/>
-                <a:ea typeface="Open Sans" panose="020B0606030504020204" pitchFamily="34" charset="0"/>
-                <a:cs typeface="Open Sans" panose="020B0606030504020204" pitchFamily="34" charset="0"/>
+                <a:latin typeface="Open Sans Light" panose="020B0606030504020204" pitchFamily="34" charset="0"/>
+                <a:ea typeface="Open Sans Light" panose="020B0606030504020204" pitchFamily="34" charset="0"/>
+                <a:cs typeface="Open Sans Light" panose="020B0606030504020204" pitchFamily="34" charset="0"/>
               </a:rPr>
               <a:t>Urban</a:t>
             </a:r>
             <a:r>
               <a:rPr lang="pt-BR" sz="3430" dirty="0">
-                <a:latin typeface="Open Sans" panose="020B0606030504020204" pitchFamily="34" charset="0"/>
-                <a:ea typeface="Open Sans" panose="020B0606030504020204" pitchFamily="34" charset="0"/>
-                <a:cs typeface="Open Sans" panose="020B0606030504020204" pitchFamily="34" charset="0"/>
+                <a:latin typeface="Open Sans Light" panose="020B0606030504020204" pitchFamily="34" charset="0"/>
+                <a:ea typeface="Open Sans Light" panose="020B0606030504020204" pitchFamily="34" charset="0"/>
+                <a:cs typeface="Open Sans Light" panose="020B0606030504020204" pitchFamily="34" charset="0"/>
               </a:rPr>
               <a:t> Chase foi concluído com sucesso, implementando a mecânica central de perseguição em ambiente urbano 3D e o sistema de posicionamento de obstáculos via point-</a:t>
             </a:r>
             <a:r>
               <a:rPr lang="pt-BR" sz="3430" dirty="0" err="1">
-                <a:latin typeface="Open Sans" panose="020B0606030504020204" pitchFamily="34" charset="0"/>
-                <a:ea typeface="Open Sans" panose="020B0606030504020204" pitchFamily="34" charset="0"/>
-                <a:cs typeface="Open Sans" panose="020B0606030504020204" pitchFamily="34" charset="0"/>
+                <a:latin typeface="Open Sans Light" panose="020B0606030504020204" pitchFamily="34" charset="0"/>
+                <a:ea typeface="Open Sans Light" panose="020B0606030504020204" pitchFamily="34" charset="0"/>
+                <a:cs typeface="Open Sans Light" panose="020B0606030504020204" pitchFamily="34" charset="0"/>
               </a:rPr>
               <a:t>and</a:t>
             </a:r>
             <a:r>
               <a:rPr lang="pt-BR" sz="3430" dirty="0">
-                <a:latin typeface="Open Sans" panose="020B0606030504020204" pitchFamily="34" charset="0"/>
-                <a:ea typeface="Open Sans" panose="020B0606030504020204" pitchFamily="34" charset="0"/>
-                <a:cs typeface="Open Sans" panose="020B0606030504020204" pitchFamily="34" charset="0"/>
+                <a:latin typeface="Open Sans Light" panose="020B0606030504020204" pitchFamily="34" charset="0"/>
+                <a:ea typeface="Open Sans Light" panose="020B0606030504020204" pitchFamily="34" charset="0"/>
+                <a:cs typeface="Open Sans Light" panose="020B0606030504020204" pitchFamily="34" charset="0"/>
               </a:rPr>
               <a:t>-click. O jogador perde pontuação a cada colisão que o fugitivo causa durante a fuga, criando uma relação direta entre as decisões táticas do policial e o impacto gerado no patrimônio urbano.</a:t>
             </a:r>
@@ -13665,16 +13649,16 @@
             </a:pPr>
             <a:r>
               <a:rPr lang="pt-BR" sz="3430" dirty="0">
-                <a:latin typeface="Open Sans" panose="020B0606030504020204" pitchFamily="34" charset="0"/>
-                <a:ea typeface="Open Sans" panose="020B0606030504020204" pitchFamily="34" charset="0"/>
-                <a:cs typeface="Open Sans" panose="020B0606030504020204" pitchFamily="34" charset="0"/>
+                <a:latin typeface="Open Sans Light" panose="020B0606030504020204" pitchFamily="34" charset="0"/>
+                <a:ea typeface="Open Sans Light" panose="020B0606030504020204" pitchFamily="34" charset="0"/>
+                <a:cs typeface="Open Sans Light" panose="020B0606030504020204" pitchFamily="34" charset="0"/>
               </a:rPr>
               <a:t>O comportamento autônomo do fugitivo, controlado por inteligência artificial, reage aos obstáculos posicionados e recalcula rotas em tempo real. O desenvolvimento envolveu a aplicação prática de programação em C# com Unity, e colaboração contínua entre os membros da equipe, validando tanto a proposta educativa do projeto quanto a capacidade técnica dos desenvolvedores.</a:t>
             </a:r>
             <a:endParaRPr lang="pt-BR" sz="3430" noProof="1">
-              <a:latin typeface="Open Sans" panose="020B0606030504020204" pitchFamily="34" charset="0"/>
-              <a:ea typeface="Open Sans" panose="020B0606030504020204" pitchFamily="34" charset="0"/>
-              <a:cs typeface="Open Sans" panose="020B0606030504020204" pitchFamily="34" charset="0"/>
+              <a:latin typeface="Open Sans Light" panose="020B0606030504020204" pitchFamily="34" charset="0"/>
+              <a:ea typeface="Open Sans Light" panose="020B0606030504020204" pitchFamily="34" charset="0"/>
+              <a:cs typeface="Open Sans Light" panose="020B0606030504020204" pitchFamily="34" charset="0"/>
             </a:endParaRPr>
           </a:p>
         </p:txBody>

</xml_diff>

<commit_message>
Add PDF banner and update PPTX
</commit_message>
<xml_diff>
--- a/documentos/BANNER_FECAP_1MACCOMP_CADD_2026_1.pptx
+++ b/documentos/BANNER_FECAP_1MACCOMP_CADD_2026_1.pptx
@@ -26,6 +26,17 @@
       <p:bold r:id="rId9"/>
       <p:italic r:id="rId10"/>
       <p:boldItalic r:id="rId11"/>
+    </p:embeddedFont>
+    <p:embeddedFont>
+      <p:font typeface="Open Sans ExtraBold" pitchFamily="2" charset="0"/>
+      <p:bold r:id="rId12"/>
+      <p:italic r:id="rId13"/>
+      <p:boldItalic r:id="rId14"/>
+    </p:embeddedFont>
+    <p:embeddedFont>
+      <p:font typeface="Open Sans Light" pitchFamily="2" charset="0"/>
+      <p:regular r:id="rId15"/>
+      <p:italic r:id="rId16"/>
     </p:embeddedFont>
   </p:embeddedFontLst>
   <p:defaultTextStyle>
@@ -273,7 +284,7 @@
       </p15:sldGuideLst>
     </p:ext>
     <p:ext uri="GoogleSlidesCustomDataVersion2">
-      <go:slidesCustomData xmlns="" xmlns:mc="http://schemas.openxmlformats.org/markup-compatibility/2006" xmlns:mv="urn:schemas-microsoft-com:mac:vml" xmlns:c="http://schemas.openxmlformats.org/drawingml/2006/chart" xmlns:dgm="http://schemas.openxmlformats.org/drawingml/2006/diagram" xmlns:o="urn:schemas-microsoft-com:office:office" xmlns:v="urn:schemas-microsoft-com:vml" xmlns:pvml="urn:schemas-microsoft-com:office:powerpoint" xmlns:com="http://schemas.openxmlformats.org/drawingml/2006/compatibility" xmlns:p14="http://schemas.microsoft.com/office/powerpoint/2010/main" xmlns:p15="http://schemas.microsoft.com/office/powerpoint/2012/main" xmlns:ahyp="http://schemas.microsoft.com/office/drawing/2018/hyperlinkcolor" xmlns:go="http://customooxmlschemas.google.com/" r:id="rId13" roundtripDataSignature="AMtx7mi+9yr4mDS8zg5+kfXTqvtBuST67g=="/>
+      <go:slidesCustomData xmlns="" xmlns:mc="http://schemas.openxmlformats.org/markup-compatibility/2006" xmlns:mv="urn:schemas-microsoft-com:mac:vml" xmlns:c="http://schemas.openxmlformats.org/drawingml/2006/chart" xmlns:dgm="http://schemas.openxmlformats.org/drawingml/2006/diagram" xmlns:o="urn:schemas-microsoft-com:office:office" xmlns:v="urn:schemas-microsoft-com:vml" xmlns:pvml="urn:schemas-microsoft-com:office:powerpoint" xmlns:com="http://schemas.openxmlformats.org/drawingml/2006/compatibility" xmlns:p14="http://schemas.microsoft.com/office/powerpoint/2010/main" xmlns:p15="http://schemas.microsoft.com/office/powerpoint/2012/main" xmlns:ahyp="http://schemas.microsoft.com/office/drawing/2018/hyperlinkcolor" xmlns:go="http://customooxmlschemas.google.com/" r:id="rId17" roundtripDataSignature="AMtx7mi+9yr4mDS8zg5+kfXTqvtBuST67g=="/>
     </p:ext>
   </p:extLst>
 </p:presentation>
@@ -771,7 +782,7 @@
               </a:spcAft>
               <a:buNone/>
             </a:pPr>
-            <a:endParaRPr/>
+            <a:endParaRPr dirty="0"/>
           </a:p>
         </p:txBody>
       </p:sp>
@@ -12781,25 +12792,31 @@
             <a:r>
               <a:rPr lang="pt-BR" sz="4762" noProof="1">
                 <a:solidFill>
-                  <a:srgbClr val="000000"/>
+                  <a:schemeClr val="tx1"/>
                 </a:solidFill>
                 <a:latin typeface="Open Sans Light" pitchFamily="2" charset="0"/>
                 <a:ea typeface="Open Sans Light" pitchFamily="2" charset="0"/>
                 <a:cs typeface="Open Sans Light" pitchFamily="2" charset="0"/>
                 <a:sym typeface="Open Sans"/>
               </a:rPr>
-              <a:t>Orientadores</a:t>
+              <a:t>Orientadores: Adriano Felix, David de Oliveira, Eduardo Savino, Luis Pires, </a:t>
             </a:r>
             <a:r>
               <a:rPr lang="pt-BR" sz="4762" noProof="1">
+                <a:solidFill>
+                  <a:schemeClr val="tx1"/>
+                </a:solidFill>
                 <a:latin typeface="Open Sans Light" pitchFamily="2" charset="0"/>
                 <a:ea typeface="Open Sans Light" pitchFamily="2" charset="0"/>
                 <a:cs typeface="Open Sans Light" pitchFamily="2" charset="0"/>
                 <a:sym typeface="Open Sans"/>
               </a:rPr>
-              <a:t>: Adriano Felix, David de Oliveira, Eduardo Savino, Luis Pires Renata Muniz, Victor Rosetti </a:t>
+              <a:t>Renata Muniz, Victor Rosetti </a:t>
             </a:r>
             <a:endParaRPr lang="pt-BR" noProof="1">
+              <a:solidFill>
+                <a:schemeClr val="tx1"/>
+              </a:solidFill>
               <a:latin typeface="Open Sans Light" pitchFamily="2" charset="0"/>
               <a:ea typeface="Open Sans Light" pitchFamily="2" charset="0"/>
               <a:cs typeface="Open Sans Light" pitchFamily="2" charset="0"/>
@@ -12815,7 +12832,7 @@
         </p:nvSpPr>
         <p:spPr>
           <a:xfrm>
-            <a:off x="15324243" y="15152551"/>
+            <a:off x="15099844" y="15177356"/>
             <a:ext cx="12433206" cy="533095"/>
           </a:xfrm>
           <a:prstGeom prst="rect">
@@ -12868,7 +12885,7 @@
         </p:nvSpPr>
         <p:spPr>
           <a:xfrm>
-            <a:off x="15353293" y="23110704"/>
+            <a:off x="15353290" y="23008444"/>
             <a:ext cx="12433206" cy="533095"/>
           </a:xfrm>
           <a:prstGeom prst="rect">
@@ -13133,8 +13150,8 @@
         </p:nvSpPr>
         <p:spPr>
           <a:xfrm>
-            <a:off x="15840846" y="31787102"/>
-            <a:ext cx="11400000" cy="5515356"/>
+            <a:off x="15714840" y="31592544"/>
+            <a:ext cx="11827476" cy="6334042"/>
           </a:xfrm>
           <a:prstGeom prst="rect">
             <a:avLst/>
@@ -13150,45 +13167,48 @@
           </a:bodyPr>
           <a:lstStyle/>
           <a:p>
-            <a:pPr lvl="0" algn="just">
+            <a:pPr algn="just">
               <a:lnSpc>
-                <a:spcPct val="140000"/>
+                <a:spcPct val="150000"/>
               </a:lnSpc>
             </a:pPr>
             <a:r>
-              <a:rPr lang="pt-BR" sz="3200" noProof="1">
-                <a:latin typeface="Open Sans Light" panose="020B0606030504020204" pitchFamily="34" charset="0"/>
-                <a:ea typeface="Open Sans Light" panose="020B0606030504020204" pitchFamily="34" charset="0"/>
-                <a:cs typeface="Open Sans Light" panose="020B0606030504020204" pitchFamily="34" charset="0"/>
+              <a:rPr lang="pt-BR" sz="3430" dirty="0">
+                <a:latin typeface="Open Sans Light" pitchFamily="2" charset="0"/>
+                <a:ea typeface="Open Sans Light" pitchFamily="2" charset="0"/>
+                <a:cs typeface="Open Sans Light" pitchFamily="2" charset="0"/>
               </a:rPr>
-              <a:t>SILICON &amp; SYNAPSE. Rock 'n' Roll Racing. Publicado por Interplay Productions. Super Nintendo Entertainment System, 1993.</a:t>
+              <a:t>FÓRUM BRASILEIRO DE SEGURANÇA PÚBLICA. Anuário Brasileiro de Segurança Pública 2025. São Paulo, 2025.</a:t>
             </a:r>
           </a:p>
           <a:p>
-            <a:pPr lvl="0" algn="just">
+            <a:pPr algn="just">
               <a:lnSpc>
-                <a:spcPct val="140000"/>
-              </a:lnSpc>
-            </a:pPr>
-            <a:endParaRPr lang="pt-BR" sz="3200" noProof="1">
-              <a:latin typeface="Open Sans Light" panose="020B0606030504020204" pitchFamily="34" charset="0"/>
-              <a:ea typeface="Open Sans Light" panose="020B0606030504020204" pitchFamily="34" charset="0"/>
-              <a:cs typeface="Open Sans Light" panose="020B0606030504020204" pitchFamily="34" charset="0"/>
-            </a:endParaRPr>
-          </a:p>
-          <a:p>
-            <a:pPr lvl="0" algn="just">
-              <a:lnSpc>
-                <a:spcPct val="140000"/>
+                <a:spcPct val="150000"/>
               </a:lnSpc>
             </a:pPr>
             <a:r>
-              <a:rPr lang="pt-BR" sz="3200" noProof="1">
-                <a:latin typeface="Open Sans Light" panose="020B0606030504020204" pitchFamily="34" charset="0"/>
-                <a:ea typeface="Open Sans Light" panose="020B0606030504020204" pitchFamily="34" charset="0"/>
-                <a:cs typeface="Open Sans Light" panose="020B0606030504020204" pitchFamily="34" charset="0"/>
+              <a:rPr lang="pt-BR" sz="3430" dirty="0">
+                <a:latin typeface="Open Sans Light" pitchFamily="2" charset="0"/>
+                <a:ea typeface="Open Sans Light" pitchFamily="2" charset="0"/>
+                <a:cs typeface="Open Sans Light" pitchFamily="2" charset="0"/>
               </a:rPr>
-              <a:t>YGGBRASIL EDUCAÇÃO DO FUTURO. Criando um projeto com Unity 6. [S.l.]: YouTube, 2025. Disponível em: https://youtube.com/watch?v=TBUJWUvc1Eg. Acesso em: 27 mar. 2026.</a:t>
+              <a:t>LOPES, Leandro de Souza. Percepção de segurança no Paraná: análise de fatores associados a partir de um inquérito online gamificado. Revista do Instituto Brasileiro de Segurança Pública, 2025.</a:t>
+            </a:r>
+          </a:p>
+          <a:p>
+            <a:pPr algn="just">
+              <a:lnSpc>
+                <a:spcPct val="150000"/>
+              </a:lnSpc>
+            </a:pPr>
+            <a:r>
+              <a:rPr lang="pt-BR" sz="3430" dirty="0">
+                <a:latin typeface="Open Sans Light" pitchFamily="2" charset="0"/>
+                <a:ea typeface="Open Sans Light" pitchFamily="2" charset="0"/>
+                <a:cs typeface="Open Sans Light" pitchFamily="2" charset="0"/>
+              </a:rPr>
+              <a:t>PRENSKY, Marc. Aprendizagem baseada em jogos digitais. São Paulo: Senac, 2012.</a:t>
             </a:r>
           </a:p>
         </p:txBody>
@@ -13201,8 +13221,8 @@
         </p:nvSpPr>
         <p:spPr>
           <a:xfrm>
-            <a:off x="1595875" y="31719850"/>
-            <a:ext cx="12562800" cy="6334042"/>
+            <a:off x="1553309" y="31656460"/>
+            <a:ext cx="12747315" cy="6334042"/>
           </a:xfrm>
           <a:prstGeom prst="rect">
             <a:avLst/>
@@ -13218,140 +13238,198 @@
           </a:bodyPr>
           <a:lstStyle/>
           <a:p>
-            <a:r>
-              <a:rPr lang="pt-BR" sz="3430" dirty="0">
-                <a:latin typeface="Open Sans Light" panose="020B0606030504020204" pitchFamily="34" charset="0"/>
-                <a:ea typeface="Open Sans Light" panose="020B0606030504020204" pitchFamily="34" charset="0"/>
-                <a:cs typeface="Open Sans Light" panose="020B0606030504020204" pitchFamily="34" charset="0"/>
-              </a:rPr>
-              <a:t>O jogo foi desenvolvido utilizando a </a:t>
-            </a:r>
-            <a:r>
-              <a:rPr lang="pt-BR" sz="3430" dirty="0" err="1">
-                <a:latin typeface="Open Sans Light" panose="020B0606030504020204" pitchFamily="34" charset="0"/>
-                <a:ea typeface="Open Sans Light" panose="020B0606030504020204" pitchFamily="34" charset="0"/>
-                <a:cs typeface="Open Sans Light" panose="020B0606030504020204" pitchFamily="34" charset="0"/>
-              </a:rPr>
-              <a:t>engine</a:t>
-            </a:r>
-            <a:r>
-              <a:rPr lang="pt-BR" sz="3430" dirty="0">
-                <a:latin typeface="Open Sans Light" panose="020B0606030504020204" pitchFamily="34" charset="0"/>
-                <a:ea typeface="Open Sans Light" panose="020B0606030504020204" pitchFamily="34" charset="0"/>
-                <a:cs typeface="Open Sans Light" panose="020B0606030504020204" pitchFamily="34" charset="0"/>
-              </a:rPr>
-              <a:t> Unity com programação em C#, suportando toda a lógica de perseguição, física e interação com o ambiente urbano.</a:t>
-            </a:r>
-          </a:p>
-          <a:p>
-            <a:pPr marL="571500" indent="-571500">
+            <a:pPr marL="742950" indent="-742950" algn="just">
+              <a:lnSpc>
+                <a:spcPct val="150000"/>
+              </a:lnSpc>
               <a:buFont typeface="Arial" panose="020B0604020202020204" pitchFamily="34" charset="0"/>
               <a:buChar char="•"/>
             </a:pPr>
             <a:r>
               <a:rPr lang="pt-BR" sz="3430" dirty="0">
-                <a:latin typeface="Open Sans Light" panose="020B0606030504020204" pitchFamily="34" charset="0"/>
-                <a:ea typeface="Open Sans Light" panose="020B0606030504020204" pitchFamily="34" charset="0"/>
-                <a:cs typeface="Open Sans Light" panose="020B0606030504020204" pitchFamily="34" charset="0"/>
+                <a:solidFill>
+                  <a:schemeClr val="tx1"/>
+                </a:solidFill>
+                <a:latin typeface="Open Sans Light" pitchFamily="2" charset="0"/>
+                <a:ea typeface="Open Sans Light" pitchFamily="2" charset="0"/>
+                <a:cs typeface="Open Sans Light" pitchFamily="2" charset="0"/>
               </a:rPr>
-              <a:t>Unity </a:t>
+              <a:t>Unity: Desenvolvimento do ambiente 3D, física e mecânicas do jogo</a:t>
+            </a:r>
+            <a:r>
+              <a:rPr lang="pt-BR" sz="3430" dirty="0">
+                <a:solidFill>
+                  <a:schemeClr val="tx1"/>
+                </a:solidFill>
+                <a:latin typeface="Open Sans Light" pitchFamily="2" charset="0"/>
+                <a:ea typeface="Open Sans Light" pitchFamily="2" charset="0"/>
+                <a:cs typeface="Open Sans Light" pitchFamily="2" charset="0"/>
+              </a:rPr>
+              <a:t>.</a:t>
             </a:r>
           </a:p>
           <a:p>
-            <a:pPr marL="571500" indent="-571500">
+            <a:pPr marL="742950" indent="-742950" algn="just">
+              <a:lnSpc>
+                <a:spcPct val="150000"/>
+              </a:lnSpc>
               <a:buFont typeface="Arial" panose="020B0604020202020204" pitchFamily="34" charset="0"/>
               <a:buChar char="•"/>
             </a:pPr>
             <a:r>
               <a:rPr lang="pt-BR" sz="3430" dirty="0">
-                <a:latin typeface="Open Sans Light" panose="020B0606030504020204" pitchFamily="34" charset="0"/>
-                <a:ea typeface="Open Sans Light" panose="020B0606030504020204" pitchFamily="34" charset="0"/>
-                <a:cs typeface="Open Sans Light" panose="020B0606030504020204" pitchFamily="34" charset="0"/>
+                <a:solidFill>
+                  <a:schemeClr val="tx1"/>
+                </a:solidFill>
+                <a:latin typeface="Open Sans Light" pitchFamily="2" charset="0"/>
+                <a:ea typeface="Open Sans Light" pitchFamily="2" charset="0"/>
+                <a:cs typeface="Open Sans Light" pitchFamily="2" charset="0"/>
               </a:rPr>
-              <a:t>C#</a:t>
+              <a:t>C#: Lógica de programação.</a:t>
             </a:r>
           </a:p>
           <a:p>
-            <a:pPr marL="571500" indent="-571500">
+            <a:pPr marL="742950" indent="-742950" algn="just">
+              <a:lnSpc>
+                <a:spcPct val="150000"/>
+              </a:lnSpc>
+              <a:buFont typeface="Arial" panose="020B0604020202020204" pitchFamily="34" charset="0"/>
+              <a:buChar char="•"/>
+            </a:pPr>
+            <a:r>
+              <a:rPr lang="pt-BR" sz="3430" dirty="0" err="1">
+                <a:solidFill>
+                  <a:schemeClr val="tx1"/>
+                </a:solidFill>
+                <a:latin typeface="Open Sans Light" pitchFamily="2" charset="0"/>
+                <a:ea typeface="Open Sans Light" pitchFamily="2" charset="0"/>
+                <a:cs typeface="Open Sans Light" pitchFamily="2" charset="0"/>
+              </a:rPr>
+              <a:t>Git</a:t>
+            </a:r>
+            <a:r>
+              <a:rPr lang="pt-BR" sz="3430" dirty="0">
+                <a:solidFill>
+                  <a:schemeClr val="tx1"/>
+                </a:solidFill>
+                <a:latin typeface="Open Sans Light" pitchFamily="2" charset="0"/>
+                <a:ea typeface="Open Sans Light" pitchFamily="2" charset="0"/>
+                <a:cs typeface="Open Sans Light" pitchFamily="2" charset="0"/>
+              </a:rPr>
+              <a:t> e GitHub: Controle de versão e compartilhamento do código.</a:t>
+            </a:r>
+          </a:p>
+          <a:p>
+            <a:pPr marL="742950" indent="-742950" algn="just">
+              <a:lnSpc>
+                <a:spcPct val="150000"/>
+              </a:lnSpc>
+              <a:buFont typeface="Arial" panose="020B0604020202020204" pitchFamily="34" charset="0"/>
+              <a:buChar char="•"/>
+            </a:pPr>
+            <a:r>
+              <a:rPr lang="pt-BR" sz="3430" dirty="0" err="1">
+                <a:solidFill>
+                  <a:schemeClr val="tx1"/>
+                </a:solidFill>
+                <a:latin typeface="Open Sans Light" pitchFamily="2" charset="0"/>
+                <a:ea typeface="Open Sans Light" pitchFamily="2" charset="0"/>
+                <a:cs typeface="Open Sans Light" pitchFamily="2" charset="0"/>
+              </a:rPr>
+              <a:t>Kanban</a:t>
+            </a:r>
+            <a:r>
+              <a:rPr lang="pt-BR" sz="3430" dirty="0">
+                <a:solidFill>
+                  <a:schemeClr val="tx1"/>
+                </a:solidFill>
+                <a:latin typeface="Open Sans Light" pitchFamily="2" charset="0"/>
+                <a:ea typeface="Open Sans Light" pitchFamily="2" charset="0"/>
+                <a:cs typeface="Open Sans Light" pitchFamily="2" charset="0"/>
+              </a:rPr>
+              <a:t>: Organização das tarefas do projeto.</a:t>
+            </a:r>
+          </a:p>
+          <a:p>
+            <a:pPr marL="742950" indent="-742950" algn="just">
+              <a:lnSpc>
+                <a:spcPct val="150000"/>
+              </a:lnSpc>
+              <a:buFont typeface="Arial" panose="020B0604020202020204" pitchFamily="34" charset="0"/>
+              <a:buChar char="•"/>
+            </a:pPr>
+            <a:r>
+              <a:rPr lang="pt-BR" sz="3430" dirty="0" err="1">
+                <a:solidFill>
+                  <a:schemeClr val="tx1"/>
+                </a:solidFill>
+                <a:latin typeface="Open Sans Light" pitchFamily="2" charset="0"/>
+                <a:ea typeface="Open Sans Light" pitchFamily="2" charset="0"/>
+                <a:cs typeface="Open Sans Light" pitchFamily="2" charset="0"/>
+              </a:rPr>
+              <a:t>Notion</a:t>
+            </a:r>
+            <a:r>
+              <a:rPr lang="pt-BR" sz="3430" dirty="0">
+                <a:solidFill>
+                  <a:schemeClr val="tx1"/>
+                </a:solidFill>
+                <a:latin typeface="Open Sans Light" pitchFamily="2" charset="0"/>
+                <a:ea typeface="Open Sans Light" pitchFamily="2" charset="0"/>
+                <a:cs typeface="Open Sans Light" pitchFamily="2" charset="0"/>
+              </a:rPr>
+              <a:t>: P</a:t>
+            </a:r>
+            <a:r>
+              <a:rPr lang="pt-BR" sz="3430" dirty="0">
+                <a:solidFill>
+                  <a:schemeClr val="tx1"/>
+                </a:solidFill>
+                <a:latin typeface="Open Sans Light" pitchFamily="2" charset="0"/>
+                <a:ea typeface="Open Sans Light" pitchFamily="2" charset="0"/>
+                <a:cs typeface="Open Sans Light" pitchFamily="2" charset="0"/>
+              </a:rPr>
+              <a:t>lanejamento da equipe</a:t>
+            </a:r>
+            <a:r>
+              <a:rPr lang="pt-BR" sz="3430" dirty="0">
+                <a:solidFill>
+                  <a:schemeClr val="tx1"/>
+                </a:solidFill>
+                <a:latin typeface="Open Sans Light" pitchFamily="2" charset="0"/>
+                <a:ea typeface="Open Sans Light" pitchFamily="2" charset="0"/>
+                <a:cs typeface="Open Sans Light" pitchFamily="2" charset="0"/>
+              </a:rPr>
+              <a:t>.</a:t>
+            </a:r>
+          </a:p>
+          <a:p>
+            <a:pPr marL="742950" indent="-742950" algn="just">
+              <a:lnSpc>
+                <a:spcPct val="150000"/>
+              </a:lnSpc>
               <a:buFont typeface="Arial" panose="020B0604020202020204" pitchFamily="34" charset="0"/>
               <a:buChar char="•"/>
             </a:pPr>
             <a:r>
               <a:rPr lang="pt-BR" sz="3430" dirty="0">
-                <a:latin typeface="Open Sans Light" panose="020B0606030504020204" pitchFamily="34" charset="0"/>
-                <a:ea typeface="Open Sans Light" panose="020B0606030504020204" pitchFamily="34" charset="0"/>
-                <a:cs typeface="Open Sans Light" panose="020B0606030504020204" pitchFamily="34" charset="0"/>
+                <a:solidFill>
+                  <a:schemeClr val="tx1"/>
+                </a:solidFill>
+                <a:latin typeface="Open Sans Light" pitchFamily="2" charset="0"/>
+                <a:ea typeface="Open Sans Light" pitchFamily="2" charset="0"/>
+                <a:cs typeface="Open Sans Light" pitchFamily="2" charset="0"/>
               </a:rPr>
-              <a:t>GitHub </a:t>
+              <a:t>Claude IA: Apoio técnico</a:t>
             </a:r>
-          </a:p>
-          <a:p>
-            <a:pPr marL="571500" indent="-571500">
-              <a:buFont typeface="Arial" panose="020B0604020202020204" pitchFamily="34" charset="0"/>
-              <a:buChar char="•"/>
-            </a:pPr>
-            <a:r>
-              <a:rPr lang="pt-BR" sz="3430" dirty="0" err="1">
-                <a:latin typeface="Open Sans Light" panose="020B0606030504020204" pitchFamily="34" charset="0"/>
-                <a:ea typeface="Open Sans Light" panose="020B0606030504020204" pitchFamily="34" charset="0"/>
-                <a:cs typeface="Open Sans Light" panose="020B0606030504020204" pitchFamily="34" charset="0"/>
-              </a:rPr>
-              <a:t>Kanban</a:t>
-            </a:r>
-            <a:r>
-              <a:rPr lang="pt-BR" sz="3430" dirty="0">
-                <a:latin typeface="Open Sans Light" panose="020B0606030504020204" pitchFamily="34" charset="0"/>
-                <a:ea typeface="Open Sans Light" panose="020B0606030504020204" pitchFamily="34" charset="0"/>
-                <a:cs typeface="Open Sans Light" panose="020B0606030504020204" pitchFamily="34" charset="0"/>
-              </a:rPr>
-              <a:t> </a:t>
-            </a:r>
-          </a:p>
-          <a:p>
-            <a:pPr marL="571500" indent="-571500">
-              <a:buFont typeface="Arial" panose="020B0604020202020204" pitchFamily="34" charset="0"/>
-              <a:buChar char="•"/>
-            </a:pPr>
-            <a:r>
-              <a:rPr lang="pt-BR" sz="3430" dirty="0" err="1">
-                <a:latin typeface="Open Sans Light" panose="020B0606030504020204" pitchFamily="34" charset="0"/>
-                <a:ea typeface="Open Sans Light" panose="020B0606030504020204" pitchFamily="34" charset="0"/>
-                <a:cs typeface="Open Sans Light" panose="020B0606030504020204" pitchFamily="34" charset="0"/>
-              </a:rPr>
-              <a:t>Notion</a:t>
-            </a:r>
-            <a:r>
-              <a:rPr lang="pt-BR" sz="3430" dirty="0">
-                <a:latin typeface="Open Sans Light" panose="020B0606030504020204" pitchFamily="34" charset="0"/>
-                <a:ea typeface="Open Sans Light" panose="020B0606030504020204" pitchFamily="34" charset="0"/>
-                <a:cs typeface="Open Sans Light" panose="020B0606030504020204" pitchFamily="34" charset="0"/>
-              </a:rPr>
-              <a:t> </a:t>
-            </a:r>
-          </a:p>
-          <a:p>
-            <a:pPr marL="571500" indent="-571500">
-              <a:buFont typeface="Arial" panose="020B0604020202020204" pitchFamily="34" charset="0"/>
-              <a:buChar char="•"/>
-            </a:pPr>
-            <a:r>
-              <a:rPr lang="pt-BR" sz="3430" dirty="0">
-                <a:latin typeface="Open Sans Light" panose="020B0606030504020204" pitchFamily="34" charset="0"/>
-                <a:ea typeface="Open Sans Light" panose="020B0606030504020204" pitchFamily="34" charset="0"/>
-                <a:cs typeface="Open Sans Light" panose="020B0606030504020204" pitchFamily="34" charset="0"/>
-              </a:rPr>
-              <a:t>Claude IA</a:t>
-            </a:r>
-          </a:p>
-          <a:p>
-            <a:r>
-              <a:rPr lang="pt-BR" sz="3430" dirty="0">
-                <a:latin typeface="Open Sans Light" panose="020B0606030504020204" pitchFamily="34" charset="0"/>
-                <a:ea typeface="Open Sans Light" panose="020B0606030504020204" pitchFamily="34" charset="0"/>
-                <a:cs typeface="Open Sans Light" panose="020B0606030504020204" pitchFamily="34" charset="0"/>
-              </a:rPr>
-              <a:t>Controle de versão, gestão de tarefas, organização do projeto e suporte com inteligência artificial integrados ao fluxo de desenvolvimento.</a:t>
-            </a:r>
+            <a:endParaRPr lang="pt-BR" sz="3430" dirty="0">
+              <a:solidFill>
+                <a:schemeClr val="tx1"/>
+              </a:solidFill>
+              <a:latin typeface="Open Sans Light" pitchFamily="2" charset="0"/>
+              <a:ea typeface="Open Sans Light" pitchFamily="2" charset="0"/>
+              <a:cs typeface="Open Sans Light" pitchFamily="2" charset="0"/>
+            </a:endParaRPr>
           </a:p>
         </p:txBody>
       </p:sp>
@@ -13363,8 +13441,8 @@
         </p:nvSpPr>
         <p:spPr>
           <a:xfrm>
-            <a:off x="1595870" y="10749184"/>
-            <a:ext cx="12562800" cy="7389844"/>
+            <a:off x="1475104" y="10797897"/>
+            <a:ext cx="12804342" cy="8709307"/>
           </a:xfrm>
           <a:prstGeom prst="rect">
             <a:avLst/>
@@ -13380,28 +13458,34 @@
           </a:bodyPr>
           <a:lstStyle/>
           <a:p>
-            <a:pPr lvl="0" algn="just">
+            <a:pPr algn="just">
               <a:lnSpc>
-                <a:spcPct val="140000"/>
+                <a:spcPct val="150000"/>
               </a:lnSpc>
             </a:pPr>
             <a:r>
               <a:rPr lang="pt-BR" sz="3430" dirty="0">
-                <a:latin typeface="Open Sans Light" panose="020B0606030504020204" pitchFamily="34" charset="0"/>
-                <a:ea typeface="Open Sans Light" panose="020B0606030504020204" pitchFamily="34" charset="0"/>
-                <a:cs typeface="Open Sans Light" panose="020B0606030504020204" pitchFamily="34" charset="0"/>
+                <a:latin typeface="Open Sans Light" pitchFamily="2" charset="0"/>
+                <a:ea typeface="Open Sans Light" pitchFamily="2" charset="0"/>
+                <a:cs typeface="Open Sans Light" pitchFamily="2" charset="0"/>
               </a:rPr>
-              <a:t>A depredação do patrimônio público gera prejuízos diretos à coletividade, comprometendo recursos e serviços que pertencem a todos. Monumentos, vias e equipamentos urbanos danificados representam custos que recaem sobre a população, degradando a qualidade de vida nas cidades e afastando investimentos do espaço urbano. Agentes de segurança, por sua vez, enfrentam o desafio cotidiano de conter essas ocorrências sem agravar ainda mais os danos ao ambiente e às pessoas ao redor, precisando tomar decisões rápidas e precisas em situações imprevisíveis onde qualquer erro tem consequências coletivas.</a:t>
+              <a:t>A depredação do patrimônio público gera prejuízos diretos à coletividade, comprometendo recursos e serviços essenciais à população. Atos de vandalismo urbano impactam diretamente a qualidade de vida, aumentam gastos públicos e contribuem para a sensação de insegurança social (FÓRUM BRASILEIRO DE SEGURANÇA PÚBLICA, 2025).</a:t>
             </a:r>
-            <a:endParaRPr lang="pt-BR" sz="3430" noProof="1">
-              <a:solidFill>
-                <a:srgbClr val="000000"/>
-              </a:solidFill>
-              <a:latin typeface="Open Sans Light" panose="020B0606030504020204" pitchFamily="34" charset="0"/>
-              <a:ea typeface="Open Sans Light" panose="020B0606030504020204" pitchFamily="34" charset="0"/>
-              <a:cs typeface="Open Sans Light" panose="020B0606030504020204" pitchFamily="34" charset="0"/>
-              <a:sym typeface="Open Sans"/>
-            </a:endParaRPr>
+          </a:p>
+          <a:p>
+            <a:pPr algn="just">
+              <a:lnSpc>
+                <a:spcPct val="150000"/>
+              </a:lnSpc>
+            </a:pPr>
+            <a:r>
+              <a:rPr lang="pt-BR" sz="3430" dirty="0">
+                <a:latin typeface="Open Sans Light" pitchFamily="2" charset="0"/>
+                <a:ea typeface="Open Sans Light" pitchFamily="2" charset="0"/>
+                <a:cs typeface="Open Sans Light" pitchFamily="2" charset="0"/>
+              </a:rPr>
+              <a:t>A percepção de segurança da população está diretamente ligada à preservação dos espaços urbanos e à confiança nas instituições públicas (LOPES, 2025). Nesse contexto, agentes de segurança enfrentam o desafio de conter ocorrências sem ampliar os danos ao patrimônio e às pessoas ao redor. </a:t>
+            </a:r>
           </a:p>
         </p:txBody>
       </p:sp>
@@ -13413,8 +13497,8 @@
         </p:nvSpPr>
         <p:spPr>
           <a:xfrm>
-            <a:off x="1670967" y="21254425"/>
-            <a:ext cx="12399470" cy="8128828"/>
+            <a:off x="1367135" y="21172965"/>
+            <a:ext cx="12968622" cy="8709307"/>
           </a:xfrm>
           <a:prstGeom prst="rect">
             <a:avLst/>
@@ -13430,32 +13514,66 @@
           </a:bodyPr>
           <a:lstStyle/>
           <a:p>
-            <a:pPr lvl="0" algn="just">
+            <a:pPr algn="just">
               <a:lnSpc>
-                <a:spcPct val="140000"/>
+                <a:spcPct val="150000"/>
               </a:lnSpc>
             </a:pPr>
             <a:r>
-              <a:rPr lang="pt-BR" sz="3430" dirty="0" err="1">
-                <a:latin typeface="Open Sans Light" panose="020B0606030504020204" pitchFamily="34" charset="0"/>
-                <a:ea typeface="Open Sans Light" panose="020B0606030504020204" pitchFamily="34" charset="0"/>
-                <a:cs typeface="Open Sans Light" panose="020B0606030504020204" pitchFamily="34" charset="0"/>
+              <a:rPr lang="pt-BR" sz="3430" dirty="0">
+                <a:latin typeface="Open Sans Light" pitchFamily="2" charset="0"/>
+                <a:ea typeface="Open Sans Light" pitchFamily="2" charset="0"/>
+                <a:cs typeface="Open Sans Light" pitchFamily="2" charset="0"/>
+              </a:rPr>
+              <a:t>Diante do crescimento dos casos de vandalismo urbano e dos prejuízos causados ao patrimônio público, a equipe desenvolveu o “</a:t>
+            </a:r>
+            <a:r>
+              <a:rPr lang="pt-BR" sz="3430" i="1" dirty="0" err="1">
+                <a:latin typeface="Open Sans ExtraBold" pitchFamily="2" charset="0"/>
+                <a:ea typeface="Open Sans ExtraBold" pitchFamily="2" charset="0"/>
+                <a:cs typeface="Open Sans ExtraBold" pitchFamily="2" charset="0"/>
               </a:rPr>
               <a:t>Urban</a:t>
             </a:r>
             <a:r>
+              <a:rPr lang="pt-BR" sz="3430" i="1" dirty="0">
+                <a:latin typeface="Open Sans ExtraBold" pitchFamily="2" charset="0"/>
+                <a:ea typeface="Open Sans ExtraBold" pitchFamily="2" charset="0"/>
+                <a:cs typeface="Open Sans ExtraBold" pitchFamily="2" charset="0"/>
+              </a:rPr>
+              <a:t> Chase”</a:t>
+            </a:r>
+            <a:r>
+              <a:rPr lang="pt-BR" sz="3430" b="1" dirty="0">
+                <a:latin typeface="Open Sans ExtraBold" pitchFamily="2" charset="0"/>
+                <a:ea typeface="Open Sans ExtraBold" pitchFamily="2" charset="0"/>
+                <a:cs typeface="Open Sans ExtraBold" pitchFamily="2" charset="0"/>
+              </a:rPr>
+              <a:t> </a:t>
+            </a:r>
+            <a:r>
               <a:rPr lang="pt-BR" sz="3430" dirty="0">
-                <a:latin typeface="Open Sans Light" panose="020B0606030504020204" pitchFamily="34" charset="0"/>
-                <a:ea typeface="Open Sans Light" panose="020B0606030504020204" pitchFamily="34" charset="0"/>
-                <a:cs typeface="Open Sans Light" panose="020B0606030504020204" pitchFamily="34" charset="0"/>
+                <a:latin typeface="Open Sans Light" pitchFamily="2" charset="0"/>
+                <a:ea typeface="Open Sans Light" pitchFamily="2" charset="0"/>
+                <a:cs typeface="Open Sans Light" pitchFamily="2" charset="0"/>
               </a:rPr>
-              <a:t> Chase é um jogo 3D em terceira pessoa que coloca o jogador no papel do Detetive Paul, um agente responsável por interceptar um fugitivo em ambiente urbano utilizando estratégia e raciocínio tático. Por meio de mecânicas de ponto e clique, o jogador posiciona obstáculos no cenário para conter o avanço do vândalo, vivenciando na prática a dificuldade de agir com eficiência sem causar danos colaterais à cidade e aos cidadãos. Essa experiência gamificada promove a conscientização sobre os impactos individuais e coletivos da depredação do patrimônio público, unindo entretenimento e reflexão social.</a:t>
+              <a:t>com o objetivo de promover conscientização social por meio da gamificação. O projeto foi motivado pela necessidade de representar, de forma interativa, os desafios enfrentados por agentes de segurança ao tentar conter criminosos sem causar danos à cidade e à população.</a:t>
             </a:r>
-            <a:endParaRPr lang="pt-BR" sz="3430" noProof="1">
-              <a:latin typeface="Open Sans Light" panose="020B0606030504020204" pitchFamily="34" charset="0"/>
-              <a:ea typeface="Open Sans Light" panose="020B0606030504020204" pitchFamily="34" charset="0"/>
-              <a:cs typeface="Open Sans Light" panose="020B0606030504020204" pitchFamily="34" charset="0"/>
-            </a:endParaRPr>
+          </a:p>
+          <a:p>
+            <a:pPr algn="just">
+              <a:lnSpc>
+                <a:spcPct val="150000"/>
+              </a:lnSpc>
+            </a:pPr>
+            <a:r>
+              <a:rPr lang="pt-BR" sz="3430" dirty="0">
+                <a:latin typeface="Open Sans Light" pitchFamily="2" charset="0"/>
+                <a:ea typeface="Open Sans Light" pitchFamily="2" charset="0"/>
+                <a:cs typeface="Open Sans Light" pitchFamily="2" charset="0"/>
+              </a:rPr>
+              <a:t>A proposta utiliza conceitos de gamificação aplicados à educação e à conscientização social, prática considerada eficiente para aumentar o engajamento e o aprendizado em ambientes digitais (PRENSKY, 2012).</a:t>
+            </a:r>
           </a:p>
         </p:txBody>
       </p:sp>
@@ -13557,7 +13675,7 @@
         <p:spPr>
           <a:xfrm>
             <a:off x="15617816" y="10880630"/>
-            <a:ext cx="11904157" cy="3694858"/>
+            <a:ext cx="11904157" cy="3958776"/>
           </a:xfrm>
           <a:prstGeom prst="rect">
             <a:avLst/>
@@ -13573,46 +13691,70 @@
           </a:bodyPr>
           <a:lstStyle/>
           <a:p>
-            <a:pPr algn="just"/>
+            <a:pPr algn="just">
+              <a:lnSpc>
+                <a:spcPct val="150000"/>
+              </a:lnSpc>
+            </a:pPr>
             <a:r>
               <a:rPr lang="pt-BR" sz="3430" dirty="0">
-                <a:latin typeface="Open Sans Light" panose="020B0606030504020204" pitchFamily="34" charset="0"/>
-                <a:ea typeface="Open Sans Light" panose="020B0606030504020204" pitchFamily="34" charset="0"/>
-                <a:cs typeface="Open Sans Light" panose="020B0606030504020204" pitchFamily="34" charset="0"/>
+                <a:latin typeface="Open Sans Light" pitchFamily="2" charset="0"/>
+                <a:ea typeface="Open Sans Light" pitchFamily="2" charset="0"/>
+                <a:cs typeface="Open Sans Light" pitchFamily="2" charset="0"/>
               </a:rPr>
-              <a:t>O game </a:t>
+              <a:t>O </a:t>
             </a:r>
             <a:r>
-              <a:rPr lang="pt-BR" sz="3430" dirty="0" err="1">
-                <a:latin typeface="Open Sans Light" panose="020B0606030504020204" pitchFamily="34" charset="0"/>
-                <a:ea typeface="Open Sans Light" panose="020B0606030504020204" pitchFamily="34" charset="0"/>
-                <a:cs typeface="Open Sans Light" panose="020B0606030504020204" pitchFamily="34" charset="0"/>
+              <a:rPr lang="pt-BR" sz="3430" i="1" dirty="0" err="1">
+                <a:solidFill>
+                  <a:schemeClr val="tx1"/>
+                </a:solidFill>
+                <a:latin typeface="Open Sans ExtraBold" pitchFamily="2" charset="0"/>
+                <a:ea typeface="Open Sans ExtraBold" pitchFamily="2" charset="0"/>
+                <a:cs typeface="Open Sans ExtraBold" pitchFamily="2" charset="0"/>
               </a:rPr>
               <a:t>Urban</a:t>
             </a:r>
             <a:r>
-              <a:rPr lang="pt-BR" sz="3430" dirty="0">
-                <a:latin typeface="Open Sans Light" panose="020B0606030504020204" pitchFamily="34" charset="0"/>
-                <a:ea typeface="Open Sans Light" panose="020B0606030504020204" pitchFamily="34" charset="0"/>
-                <a:cs typeface="Open Sans Light" panose="020B0606030504020204" pitchFamily="34" charset="0"/>
+              <a:rPr lang="pt-BR" sz="3430" i="1" dirty="0">
+                <a:solidFill>
+                  <a:schemeClr val="tx1"/>
+                </a:solidFill>
+                <a:latin typeface="Open Sans ExtraBold" pitchFamily="2" charset="0"/>
+                <a:ea typeface="Open Sans ExtraBold" pitchFamily="2" charset="0"/>
+                <a:cs typeface="Open Sans ExtraBold" pitchFamily="2" charset="0"/>
               </a:rPr>
-              <a:t> Chase foi concluído com sucesso, implementando a mecânica central de perseguição em ambiente urbano 3D e o sistema de posicionamento de obstáculos via point-</a:t>
+              <a:t> </a:t>
             </a:r>
             <a:r>
-              <a:rPr lang="pt-BR" sz="3430" dirty="0" err="1">
-                <a:latin typeface="Open Sans Light" panose="020B0606030504020204" pitchFamily="34" charset="0"/>
-                <a:ea typeface="Open Sans Light" panose="020B0606030504020204" pitchFamily="34" charset="0"/>
-                <a:cs typeface="Open Sans Light" panose="020B0606030504020204" pitchFamily="34" charset="0"/>
+              <a:rPr lang="pt-BR" sz="3430" i="1" dirty="0">
+                <a:solidFill>
+                  <a:schemeClr val="tx1"/>
+                </a:solidFill>
+                <a:latin typeface="Open Sans ExtraBold" pitchFamily="2" charset="0"/>
+                <a:ea typeface="Open Sans ExtraBold" pitchFamily="2" charset="0"/>
+                <a:cs typeface="Open Sans ExtraBold" pitchFamily="2" charset="0"/>
               </a:rPr>
-              <a:t>and</a:t>
+              <a:t>Chase</a:t>
             </a:r>
             <a:r>
               <a:rPr lang="pt-BR" sz="3430" dirty="0">
-                <a:latin typeface="Open Sans Light" panose="020B0606030504020204" pitchFamily="34" charset="0"/>
-                <a:ea typeface="Open Sans Light" panose="020B0606030504020204" pitchFamily="34" charset="0"/>
-                <a:cs typeface="Open Sans Light" panose="020B0606030504020204" pitchFamily="34" charset="0"/>
+                <a:solidFill>
+                  <a:schemeClr val="tx1"/>
+                </a:solidFill>
+                <a:latin typeface="Open Sans Light" pitchFamily="2" charset="0"/>
+                <a:ea typeface="Open Sans Light" pitchFamily="2" charset="0"/>
+                <a:cs typeface="Open Sans Light" pitchFamily="2" charset="0"/>
               </a:rPr>
-              <a:t>-click. O jogador perde pontuação a cada colisão que o fugitivo causa durante a fuga, criando uma relação direta entre as decisões táticas do policial e o impacto gerado no patrimônio urbano.</a:t>
+              <a:t> </a:t>
+            </a:r>
+            <a:r>
+              <a:rPr lang="pt-BR" sz="3430" dirty="0">
+                <a:latin typeface="Open Sans Light" pitchFamily="2" charset="0"/>
+                <a:ea typeface="Open Sans Light" pitchFamily="2" charset="0"/>
+                <a:cs typeface="Open Sans Light" pitchFamily="2" charset="0"/>
+              </a:rPr>
+              <a:t>foi desenvolvido com sucesso, implementando mecânicas de perseguição urbana em ambiente 3D, inteligência artificial para movimentação do fugitivo e sistemas estratégicos de obstáculos posicionados pelo jogador.</a:t>
             </a:r>
           </a:p>
         </p:txBody>
@@ -13626,7 +13768,7 @@
         <p:spPr>
           <a:xfrm>
             <a:off x="15714839" y="23891010"/>
-            <a:ext cx="11652014" cy="5172891"/>
+            <a:ext cx="11807134" cy="5542286"/>
           </a:xfrm>
           <a:prstGeom prst="rect">
             <a:avLst/>
@@ -13642,24 +13784,74 @@
           </a:bodyPr>
           <a:lstStyle/>
           <a:p>
-            <a:pPr lvl="0" algn="just">
+            <a:pPr algn="just">
               <a:lnSpc>
-                <a:spcPct val="140000"/>
+                <a:spcPct val="150000"/>
               </a:lnSpc>
             </a:pPr>
             <a:r>
               <a:rPr lang="pt-BR" sz="3430" dirty="0">
-                <a:latin typeface="Open Sans Light" panose="020B0606030504020204" pitchFamily="34" charset="0"/>
-                <a:ea typeface="Open Sans Light" panose="020B0606030504020204" pitchFamily="34" charset="0"/>
-                <a:cs typeface="Open Sans Light" panose="020B0606030504020204" pitchFamily="34" charset="0"/>
+                <a:latin typeface="Open Sans Light" pitchFamily="2" charset="0"/>
+                <a:ea typeface="Open Sans Light" pitchFamily="2" charset="0"/>
+                <a:cs typeface="Open Sans Light" pitchFamily="2" charset="0"/>
               </a:rPr>
-              <a:t>O comportamento autônomo do fugitivo, controlado por inteligência artificial, reage aos obstáculos posicionados e recalcula rotas em tempo real. O desenvolvimento envolveu a aplicação prática de programação em C# com Unity, e colaboração contínua entre os membros da equipe, validando tanto a proposta educativa do projeto quanto a capacidade técnica dos desenvolvedores.</a:t>
+              <a:t>O jogador controla o policial com movimentação WASD e utiliza mecânicas </a:t>
             </a:r>
-            <a:endParaRPr lang="pt-BR" sz="3430" noProof="1">
-              <a:latin typeface="Open Sans Light" panose="020B0606030504020204" pitchFamily="34" charset="0"/>
-              <a:ea typeface="Open Sans Light" panose="020B0606030504020204" pitchFamily="34" charset="0"/>
-              <a:cs typeface="Open Sans Light" panose="020B0606030504020204" pitchFamily="34" charset="0"/>
-            </a:endParaRPr>
+            <a:r>
+              <a:rPr lang="pt-BR" sz="3430" i="1" dirty="0">
+                <a:latin typeface="Open Sans ExtraBold" pitchFamily="2" charset="0"/>
+                <a:ea typeface="Open Sans ExtraBold" pitchFamily="2" charset="0"/>
+                <a:cs typeface="Open Sans ExtraBold" pitchFamily="2" charset="0"/>
+              </a:rPr>
+              <a:t>point-</a:t>
+            </a:r>
+            <a:r>
+              <a:rPr lang="pt-BR" sz="3430" i="1" dirty="0" err="1">
+                <a:latin typeface="Open Sans ExtraBold" pitchFamily="2" charset="0"/>
+                <a:ea typeface="Open Sans ExtraBold" pitchFamily="2" charset="0"/>
+                <a:cs typeface="Open Sans ExtraBold" pitchFamily="2" charset="0"/>
+              </a:rPr>
+              <a:t>and</a:t>
+            </a:r>
+            <a:r>
+              <a:rPr lang="pt-BR" sz="3430" i="1" dirty="0">
+                <a:latin typeface="Open Sans ExtraBold" pitchFamily="2" charset="0"/>
+                <a:ea typeface="Open Sans ExtraBold" pitchFamily="2" charset="0"/>
+                <a:cs typeface="Open Sans ExtraBold" pitchFamily="2" charset="0"/>
+              </a:rPr>
+              <a:t>-click</a:t>
+            </a:r>
+            <a:r>
+              <a:rPr lang="pt-BR" sz="3430" dirty="0">
+                <a:latin typeface="Open Sans Light" pitchFamily="2" charset="0"/>
+                <a:ea typeface="Open Sans Light" pitchFamily="2" charset="0"/>
+                <a:cs typeface="Open Sans Light" pitchFamily="2" charset="0"/>
+              </a:rPr>
+              <a:t> para posicionar obstáculos no cenário. O fugitivo reage dinamicamente aos obstáculos, alterando sua rota em tempo real.</a:t>
+            </a:r>
+          </a:p>
+          <a:p>
+            <a:pPr>
+              <a:lnSpc>
+                <a:spcPct val="150000"/>
+              </a:lnSpc>
+            </a:pPr>
+            <a:r>
+              <a:rPr lang="pt-BR" sz="3430" dirty="0">
+                <a:latin typeface="Open Sans Light" pitchFamily="2" charset="0"/>
+                <a:ea typeface="Open Sans Light" pitchFamily="2" charset="0"/>
+                <a:cs typeface="Open Sans Light" pitchFamily="2" charset="0"/>
+              </a:rPr>
+              <a:t>O jogo reforça a conscientização sobre os impactos da depredação urbana e permitiu a aplicação prática de programação, lógica computacional e trabalho em equipe</a:t>
+            </a:r>
+            <a:r>
+              <a:rPr lang="pt-BR" sz="3430" dirty="0">
+                <a:latin typeface="Open Sans Light" pitchFamily="2" charset="0"/>
+                <a:ea typeface="Open Sans Light" pitchFamily="2" charset="0"/>
+                <a:cs typeface="Open Sans Light" pitchFamily="2" charset="0"/>
+              </a:rPr>
+              <a:t>.</a:t>
+            </a:r>
           </a:p>
         </p:txBody>
       </p:sp>
@@ -13685,7 +13877,7 @@
         </p:blipFill>
         <p:spPr>
           <a:xfrm>
-            <a:off x="15918469" y="16198183"/>
+            <a:off x="15889422" y="16123380"/>
             <a:ext cx="11302847" cy="6490662"/>
           </a:xfrm>
           <a:prstGeom prst="rect">

</xml_diff>